<commit_message>
chore: remove outdated documentation and update blockchain data
- Deleted Documentation.zip and temporary presentation file from the documentation directory.
- Updated chain_data.json with the latest lastUpdated and currentBlock values for accurate blockchain state.
</commit_message>
<xml_diff>
--- a/Documentation/QChat_Presentation_UENR.pptx
+++ b/Documentation/QChat_Presentation_UENR.pptx
@@ -7453,7 +7453,7 @@
             <a:r>
               <a:rPr sz="3400" b="1" i="0">
                 <a:solidFill>
-                  <a:srgbClr val="00336A"/>
+                  <a:srgbClr val="FFFFFF"/>
                 </a:solidFill>
                 <a:latin typeface="Century Gothic"/>
               </a:rPr>
@@ -7533,7 +7533,7 @@
             <a:r>
               <a:rPr sz="1300" b="0" i="0">
                 <a:solidFill>
-                  <a:srgbClr val="005AA0"/>
+                  <a:srgbClr val="FFFFFF"/>
                 </a:solidFill>
                 <a:latin typeface="Century Gothic"/>
               </a:rPr>
@@ -7569,7 +7569,7 @@
             <a:r>
               <a:rPr sz="900" b="1" i="0">
                 <a:solidFill>
-                  <a:srgbClr val="00336A"/>
+                  <a:srgbClr val="FFF901"/>
                 </a:solidFill>
                 <a:latin typeface="Century Gothic"/>
               </a:rPr>
@@ -7604,7 +7604,7 @@
             <a:r>
               <a:rPr sz="1400" b="0" i="0">
                 <a:solidFill>
-                  <a:srgbClr val="00336A"/>
+                  <a:srgbClr val="FFFFFF"/>
                 </a:solidFill>
                 <a:latin typeface="Century Gothic"/>
               </a:rPr>
@@ -7639,7 +7639,7 @@
             <a:r>
               <a:rPr sz="1100" b="0" i="0">
                 <a:solidFill>
-                  <a:srgbClr val="005AA0"/>
+                  <a:srgbClr val="FFF901"/>
                 </a:solidFill>
                 <a:latin typeface="Century Gothic"/>
               </a:rPr>
@@ -7676,7 +7676,11 @@
             <p:ph idx="1"/>
           </p:nvPr>
         </p:nvSpPr>
-        <p:spPr/>
+        <p:spPr>
+          <a:xfrm>
+            <a:off x="0" y="1603063"/>
+          </a:xfrm>
+        </p:spPr>
         <p:txBody>
           <a:bodyPr/>
           <a:lstStyle/>
@@ -7693,7 +7697,11 @@
             <p:ph idx="2" sz="half"/>
           </p:nvPr>
         </p:nvSpPr>
-        <p:spPr/>
+        <p:spPr>
+          <a:xfrm>
+            <a:off x="0" y="1985790"/>
+          </a:xfrm>
+        </p:spPr>
         <p:txBody>
           <a:bodyPr/>
           <a:lstStyle/>
@@ -7899,7 +7907,7 @@
         </p:nvSpPr>
         <p:spPr>
           <a:xfrm>
-            <a:off x="274320" y="1051560"/>
+            <a:off x="274320" y="1261872"/>
             <a:ext cx="5760720" cy="411480"/>
           </a:xfrm>
           <a:prstGeom prst="rect">
@@ -7934,7 +7942,7 @@
         </p:nvSpPr>
         <p:spPr>
           <a:xfrm>
-            <a:off x="274320" y="1435607"/>
+            <a:off x="274320" y="1645919"/>
             <a:ext cx="5760720" cy="32004"/>
           </a:xfrm>
           <a:prstGeom prst="rect">
@@ -7977,7 +7985,7 @@
         </p:nvSpPr>
         <p:spPr>
           <a:xfrm>
-            <a:off x="274320" y="1527048"/>
+            <a:off x="274320" y="1737360"/>
             <a:ext cx="5760720" cy="4617720"/>
           </a:xfrm>
           <a:prstGeom prst="rect">
@@ -8128,7 +8136,7 @@
         </p:nvSpPr>
         <p:spPr>
           <a:xfrm>
-            <a:off x="6126480" y="1051560"/>
+            <a:off x="6126480" y="1261872"/>
             <a:ext cx="36576" cy="5120640"/>
           </a:xfrm>
           <a:prstGeom prst="rect">
@@ -8171,7 +8179,7 @@
         </p:nvSpPr>
         <p:spPr>
           <a:xfrm>
-            <a:off x="6291072" y="1051560"/>
+            <a:off x="6291072" y="1261872"/>
             <a:ext cx="5623560" cy="411480"/>
           </a:xfrm>
           <a:prstGeom prst="rect">
@@ -8206,7 +8214,7 @@
         </p:nvSpPr>
         <p:spPr>
           <a:xfrm>
-            <a:off x="6291072" y="1435607"/>
+            <a:off x="6291072" y="1645919"/>
             <a:ext cx="5623560" cy="32004"/>
           </a:xfrm>
           <a:prstGeom prst="rect">
@@ -8249,7 +8257,7 @@
         </p:nvSpPr>
         <p:spPr>
           <a:xfrm>
-            <a:off x="6291072" y="1527048"/>
+            <a:off x="6291072" y="1737360"/>
             <a:ext cx="5623560" cy="4617720"/>
           </a:xfrm>
           <a:prstGeom prst="rect">
@@ -8372,7 +8380,11 @@
             <p:ph idx="1"/>
           </p:nvPr>
         </p:nvSpPr>
-        <p:spPr/>
+        <p:spPr>
+          <a:xfrm>
+            <a:off x="0" y="1603063"/>
+          </a:xfrm>
+        </p:spPr>
         <p:txBody>
           <a:bodyPr/>
           <a:lstStyle/>
@@ -8389,7 +8401,11 @@
             <p:ph idx="2" sz="half"/>
           </p:nvPr>
         </p:nvSpPr>
-        <p:spPr/>
+        <p:spPr>
+          <a:xfrm>
+            <a:off x="0" y="1985790"/>
+          </a:xfrm>
+        </p:spPr>
         <p:txBody>
           <a:bodyPr/>
           <a:lstStyle/>
@@ -8595,7 +8611,7 @@
         </p:nvSpPr>
         <p:spPr>
           <a:xfrm>
-            <a:off x="274320" y="1051560"/>
+            <a:off x="274320" y="1261872"/>
             <a:ext cx="5760720" cy="411480"/>
           </a:xfrm>
           <a:prstGeom prst="rect">
@@ -8630,7 +8646,7 @@
         </p:nvSpPr>
         <p:spPr>
           <a:xfrm>
-            <a:off x="274320" y="1435607"/>
+            <a:off x="274320" y="1645919"/>
             <a:ext cx="5760720" cy="32004"/>
           </a:xfrm>
           <a:prstGeom prst="rect">
@@ -8673,7 +8689,7 @@
         </p:nvSpPr>
         <p:spPr>
           <a:xfrm>
-            <a:off x="274320" y="1527048"/>
+            <a:off x="274320" y="1737360"/>
             <a:ext cx="5760720" cy="4617720"/>
           </a:xfrm>
           <a:prstGeom prst="rect">
@@ -8760,7 +8776,7 @@
         </p:nvSpPr>
         <p:spPr>
           <a:xfrm>
-            <a:off x="6126480" y="1051560"/>
+            <a:off x="6126480" y="1261872"/>
             <a:ext cx="36576" cy="5120640"/>
           </a:xfrm>
           <a:prstGeom prst="rect">
@@ -8803,7 +8819,7 @@
         </p:nvSpPr>
         <p:spPr>
           <a:xfrm>
-            <a:off x="6291072" y="1051560"/>
+            <a:off x="6291072" y="1261872"/>
             <a:ext cx="5623560" cy="411480"/>
           </a:xfrm>
           <a:prstGeom prst="rect">
@@ -8838,7 +8854,7 @@
         </p:nvSpPr>
         <p:spPr>
           <a:xfrm>
-            <a:off x="6291072" y="1435607"/>
+            <a:off x="6291072" y="1645919"/>
             <a:ext cx="5623560" cy="32004"/>
           </a:xfrm>
           <a:prstGeom prst="rect">
@@ -8881,7 +8897,7 @@
         </p:nvSpPr>
         <p:spPr>
           <a:xfrm>
-            <a:off x="6291072" y="1527048"/>
+            <a:off x="6291072" y="1737360"/>
             <a:ext cx="5623560" cy="4617720"/>
           </a:xfrm>
           <a:prstGeom prst="rect">
@@ -8988,7 +9004,11 @@
             <p:ph idx="1"/>
           </p:nvPr>
         </p:nvSpPr>
-        <p:spPr/>
+        <p:spPr>
+          <a:xfrm>
+            <a:off x="0" y="1603063"/>
+          </a:xfrm>
+        </p:spPr>
         <p:txBody>
           <a:bodyPr/>
           <a:lstStyle/>
@@ -9005,7 +9025,11 @@
             <p:ph idx="2" sz="half"/>
           </p:nvPr>
         </p:nvSpPr>
-        <p:spPr/>
+        <p:spPr>
+          <a:xfrm>
+            <a:off x="0" y="1985790"/>
+          </a:xfrm>
+        </p:spPr>
         <p:txBody>
           <a:bodyPr/>
           <a:lstStyle/>
@@ -9211,7 +9235,7 @@
         </p:nvSpPr>
         <p:spPr>
           <a:xfrm>
-            <a:off x="274320" y="1051560"/>
+            <a:off x="274320" y="1261872"/>
             <a:ext cx="11731752" cy="5440680"/>
           </a:xfrm>
           <a:prstGeom prst="rect">
@@ -9616,7 +9640,7 @@
             <a:r>
               <a:rPr sz="2000" b="0" i="0">
                 <a:solidFill>
-                  <a:srgbClr val="3FBEF1"/>
+                  <a:srgbClr val="FFFFFF"/>
                 </a:solidFill>
                 <a:latin typeface="Century Gothic"/>
               </a:rPr>
@@ -9686,7 +9710,7 @@
             <a:r>
               <a:rPr sz="1100" b="0" i="0">
                 <a:solidFill>
-                  <a:srgbClr val="3FBEF1"/>
+                  <a:srgbClr val="FFF901"/>
                 </a:solidFill>
                 <a:latin typeface="Century Gothic"/>
               </a:rPr>
@@ -9715,6 +9739,49 @@
       <p:grpSpPr/>
       <p:sp>
         <p:nvSpPr>
+          <p:cNvPr id="46" name="HeaderBar_TOC"/>
+          <p:cNvSpPr/>
+          <p:nvPr/>
+        </p:nvSpPr>
+        <p:spPr>
+          <a:xfrm>
+            <a:off x="0" y="0"/>
+            <a:ext cx="12188952" cy="914400"/>
+          </a:xfrm>
+          <a:prstGeom prst="rect">
+            <a:avLst/>
+          </a:prstGeom>
+          <a:solidFill>
+            <a:srgbClr val="00336A"/>
+          </a:solidFill>
+          <a:ln>
+            <a:noFill/>
+          </a:ln>
+        </p:spPr>
+        <p:style>
+          <a:lnRef idx="1">
+            <a:schemeClr val="accent1"/>
+          </a:lnRef>
+          <a:fillRef idx="3">
+            <a:schemeClr val="accent1"/>
+          </a:fillRef>
+          <a:effectRef idx="2">
+            <a:schemeClr val="accent1"/>
+          </a:effectRef>
+          <a:fontRef idx="minor">
+            <a:schemeClr val="lt1"/>
+          </a:fontRef>
+        </p:style>
+        <p:txBody>
+          <a:bodyPr rtlCol="0" anchor="ctr"/>
+          <a:lstStyle/>
+          <a:p>
+            <a:pPr algn="ctr"/>
+          </a:p>
+        </p:txBody>
+      </p:sp>
+      <p:sp>
+        <p:nvSpPr>
           <p:cNvPr id="2" name="Content Placeholder 1"/>
           <p:cNvSpPr>
             <a:spLocks noGrp="1"/>
@@ -9816,7 +9883,7 @@
             <a:r>
               <a:rPr sz="2800" b="1" i="0">
                 <a:solidFill>
-                  <a:srgbClr val="00336A"/>
+                  <a:srgbClr val="FFFFFF"/>
                 </a:solidFill>
                 <a:latin typeface="Century Gothic"/>
               </a:rPr>
@@ -11405,7 +11472,11 @@
             <p:ph idx="1"/>
           </p:nvPr>
         </p:nvSpPr>
-        <p:spPr/>
+        <p:spPr>
+          <a:xfrm>
+            <a:off x="0" y="1603063"/>
+          </a:xfrm>
+        </p:spPr>
         <p:txBody>
           <a:bodyPr/>
           <a:lstStyle/>
@@ -11422,7 +11493,11 @@
             <p:ph idx="2" sz="half"/>
           </p:nvPr>
         </p:nvSpPr>
-        <p:spPr/>
+        <p:spPr>
+          <a:xfrm>
+            <a:off x="0" y="1985790"/>
+          </a:xfrm>
+        </p:spPr>
         <p:txBody>
           <a:bodyPr/>
           <a:lstStyle/>
@@ -11628,7 +11703,7 @@
         </p:nvSpPr>
         <p:spPr>
           <a:xfrm>
-            <a:off x="274320" y="1051560"/>
+            <a:off x="274320" y="1261872"/>
             <a:ext cx="11731752" cy="5440680"/>
           </a:xfrm>
           <a:prstGeom prst="rect">
@@ -11767,7 +11842,11 @@
             <p:ph idx="1"/>
           </p:nvPr>
         </p:nvSpPr>
-        <p:spPr/>
+        <p:spPr>
+          <a:xfrm>
+            <a:off x="0" y="1603063"/>
+          </a:xfrm>
+        </p:spPr>
         <p:txBody>
           <a:bodyPr/>
           <a:lstStyle/>
@@ -11784,7 +11863,11 @@
             <p:ph idx="2" sz="half"/>
           </p:nvPr>
         </p:nvSpPr>
-        <p:spPr/>
+        <p:spPr>
+          <a:xfrm>
+            <a:off x="0" y="1985790"/>
+          </a:xfrm>
+        </p:spPr>
         <p:txBody>
           <a:bodyPr/>
           <a:lstStyle/>
@@ -11990,7 +12073,7 @@
         </p:nvSpPr>
         <p:spPr>
           <a:xfrm>
-            <a:off x="274320" y="1051560"/>
+            <a:off x="274320" y="1261872"/>
             <a:ext cx="11731752" cy="5440680"/>
           </a:xfrm>
           <a:prstGeom prst="rect">
@@ -12161,7 +12244,11 @@
             <p:ph idx="1"/>
           </p:nvPr>
         </p:nvSpPr>
-        <p:spPr/>
+        <p:spPr>
+          <a:xfrm>
+            <a:off x="0" y="1603063"/>
+          </a:xfrm>
+        </p:spPr>
         <p:txBody>
           <a:bodyPr/>
           <a:lstStyle/>
@@ -12178,7 +12265,11 @@
             <p:ph idx="2" sz="half"/>
           </p:nvPr>
         </p:nvSpPr>
-        <p:spPr/>
+        <p:spPr>
+          <a:xfrm>
+            <a:off x="0" y="1985790"/>
+          </a:xfrm>
+        </p:spPr>
         <p:txBody>
           <a:bodyPr/>
           <a:lstStyle/>
@@ -12384,7 +12475,7 @@
         </p:nvSpPr>
         <p:spPr>
           <a:xfrm>
-            <a:off x="274320" y="1024128"/>
+            <a:off x="274320" y="1234440"/>
             <a:ext cx="11686032" cy="685800"/>
           </a:xfrm>
           <a:prstGeom prst="roundRect">
@@ -12427,7 +12518,7 @@
         </p:nvSpPr>
         <p:spPr>
           <a:xfrm>
-            <a:off x="411480" y="1097280"/>
+            <a:off x="411480" y="1307592"/>
             <a:ext cx="11411712" cy="530352"/>
           </a:xfrm>
           <a:prstGeom prst="rect">
@@ -12462,7 +12553,7 @@
         </p:nvSpPr>
         <p:spPr>
           <a:xfrm>
-            <a:off x="274320" y="1874519"/>
+            <a:off x="274320" y="2084831"/>
             <a:ext cx="5760720" cy="411480"/>
           </a:xfrm>
           <a:prstGeom prst="rect">
@@ -12497,7 +12588,7 @@
         </p:nvSpPr>
         <p:spPr>
           <a:xfrm>
-            <a:off x="274320" y="2258568"/>
+            <a:off x="274320" y="2468880"/>
             <a:ext cx="5760720" cy="32004"/>
           </a:xfrm>
           <a:prstGeom prst="rect">
@@ -12540,7 +12631,7 @@
         </p:nvSpPr>
         <p:spPr>
           <a:xfrm>
-            <a:off x="274320" y="2350008"/>
+            <a:off x="274320" y="2560320"/>
             <a:ext cx="5760720" cy="3794760"/>
           </a:xfrm>
           <a:prstGeom prst="rect">
@@ -12611,7 +12702,7 @@
         </p:nvSpPr>
         <p:spPr>
           <a:xfrm>
-            <a:off x="6126480" y="1874519"/>
+            <a:off x="6126480" y="2084831"/>
             <a:ext cx="36576" cy="4297680"/>
           </a:xfrm>
           <a:prstGeom prst="rect">
@@ -12654,7 +12745,7 @@
         </p:nvSpPr>
         <p:spPr>
           <a:xfrm>
-            <a:off x="6291072" y="1874519"/>
+            <a:off x="6291072" y="2084831"/>
             <a:ext cx="5623560" cy="411480"/>
           </a:xfrm>
           <a:prstGeom prst="rect">
@@ -12689,7 +12780,7 @@
         </p:nvSpPr>
         <p:spPr>
           <a:xfrm>
-            <a:off x="6291072" y="2258568"/>
+            <a:off x="6291072" y="2468880"/>
             <a:ext cx="5623560" cy="32004"/>
           </a:xfrm>
           <a:prstGeom prst="rect">
@@ -12732,7 +12823,7 @@
         </p:nvSpPr>
         <p:spPr>
           <a:xfrm>
-            <a:off x="6291072" y="2350008"/>
+            <a:off x="6291072" y="2560320"/>
             <a:ext cx="5623560" cy="3794760"/>
           </a:xfrm>
           <a:prstGeom prst="rect">
@@ -12823,7 +12914,11 @@
             <p:ph idx="1"/>
           </p:nvPr>
         </p:nvSpPr>
-        <p:spPr/>
+        <p:spPr>
+          <a:xfrm>
+            <a:off x="0" y="1603063"/>
+          </a:xfrm>
+        </p:spPr>
         <p:txBody>
           <a:bodyPr/>
           <a:lstStyle/>
@@ -12840,7 +12935,11 @@
             <p:ph idx="2" sz="half"/>
           </p:nvPr>
         </p:nvSpPr>
-        <p:spPr/>
+        <p:spPr>
+          <a:xfrm>
+            <a:off x="0" y="1985790"/>
+          </a:xfrm>
+        </p:spPr>
         <p:txBody>
           <a:bodyPr/>
           <a:lstStyle/>
@@ -13046,7 +13145,7 @@
         </p:nvSpPr>
         <p:spPr>
           <a:xfrm>
-            <a:off x="274320" y="1051560"/>
+            <a:off x="274320" y="1261872"/>
             <a:ext cx="2011680" cy="777240"/>
           </a:xfrm>
           <a:prstGeom prst="rect">
@@ -13089,7 +13188,7 @@
         </p:nvSpPr>
         <p:spPr>
           <a:xfrm>
-            <a:off x="320040" y="1124712"/>
+            <a:off x="320040" y="1335024"/>
             <a:ext cx="1920240" cy="640080"/>
           </a:xfrm>
           <a:prstGeom prst="rect">
@@ -13124,7 +13223,7 @@
         </p:nvSpPr>
         <p:spPr>
           <a:xfrm>
-            <a:off x="2423160" y="1143000"/>
+            <a:off x="2423160" y="1353312"/>
             <a:ext cx="9509760" cy="594360"/>
           </a:xfrm>
           <a:prstGeom prst="rect">
@@ -13159,7 +13258,7 @@
         </p:nvSpPr>
         <p:spPr>
           <a:xfrm>
-            <a:off x="274320" y="1892807"/>
+            <a:off x="274320" y="2103119"/>
             <a:ext cx="11686032" cy="9144"/>
           </a:xfrm>
           <a:prstGeom prst="rect">
@@ -13202,7 +13301,7 @@
         </p:nvSpPr>
         <p:spPr>
           <a:xfrm>
-            <a:off x="274320" y="2011680"/>
+            <a:off x="274320" y="2221992"/>
             <a:ext cx="2011680" cy="777240"/>
           </a:xfrm>
           <a:prstGeom prst="rect">
@@ -13245,7 +13344,7 @@
         </p:nvSpPr>
         <p:spPr>
           <a:xfrm>
-            <a:off x="320040" y="2084832"/>
+            <a:off x="320040" y="2295144"/>
             <a:ext cx="1920240" cy="640080"/>
           </a:xfrm>
           <a:prstGeom prst="rect">
@@ -13280,7 +13379,7 @@
         </p:nvSpPr>
         <p:spPr>
           <a:xfrm>
-            <a:off x="2423160" y="2103120"/>
+            <a:off x="2423160" y="2313432"/>
             <a:ext cx="9509760" cy="594360"/>
           </a:xfrm>
           <a:prstGeom prst="rect">
@@ -13315,7 +13414,7 @@
         </p:nvSpPr>
         <p:spPr>
           <a:xfrm>
-            <a:off x="274320" y="2852928"/>
+            <a:off x="274320" y="3063240"/>
             <a:ext cx="11686032" cy="9144"/>
           </a:xfrm>
           <a:prstGeom prst="rect">
@@ -13358,7 +13457,7 @@
         </p:nvSpPr>
         <p:spPr>
           <a:xfrm>
-            <a:off x="274320" y="2971800"/>
+            <a:off x="274320" y="3182112"/>
             <a:ext cx="2011680" cy="777240"/>
           </a:xfrm>
           <a:prstGeom prst="rect">
@@ -13401,7 +13500,7 @@
         </p:nvSpPr>
         <p:spPr>
           <a:xfrm>
-            <a:off x="320040" y="3044952"/>
+            <a:off x="320040" y="3255264"/>
             <a:ext cx="1920240" cy="640080"/>
           </a:xfrm>
           <a:prstGeom prst="rect">
@@ -13436,7 +13535,7 @@
         </p:nvSpPr>
         <p:spPr>
           <a:xfrm>
-            <a:off x="2423160" y="3063240"/>
+            <a:off x="2423160" y="3273552"/>
             <a:ext cx="9509760" cy="594360"/>
           </a:xfrm>
           <a:prstGeom prst="rect">
@@ -13471,7 +13570,7 @@
         </p:nvSpPr>
         <p:spPr>
           <a:xfrm>
-            <a:off x="274320" y="3813048"/>
+            <a:off x="274320" y="4023360"/>
             <a:ext cx="11686032" cy="9144"/>
           </a:xfrm>
           <a:prstGeom prst="rect">
@@ -13514,7 +13613,7 @@
         </p:nvSpPr>
         <p:spPr>
           <a:xfrm>
-            <a:off x="274320" y="3931920"/>
+            <a:off x="274320" y="4142232"/>
             <a:ext cx="2011680" cy="777240"/>
           </a:xfrm>
           <a:prstGeom prst="rect">
@@ -13557,7 +13656,7 @@
         </p:nvSpPr>
         <p:spPr>
           <a:xfrm>
-            <a:off x="320040" y="4005072"/>
+            <a:off x="320040" y="4215384"/>
             <a:ext cx="1920240" cy="640080"/>
           </a:xfrm>
           <a:prstGeom prst="rect">
@@ -13592,7 +13691,7 @@
         </p:nvSpPr>
         <p:spPr>
           <a:xfrm>
-            <a:off x="2423160" y="4023359"/>
+            <a:off x="2423160" y="4233671"/>
             <a:ext cx="9509760" cy="594360"/>
           </a:xfrm>
           <a:prstGeom prst="rect">
@@ -13627,7 +13726,7 @@
         </p:nvSpPr>
         <p:spPr>
           <a:xfrm>
-            <a:off x="274320" y="4937759"/>
+            <a:off x="274320" y="5148071"/>
             <a:ext cx="11686032" cy="640080"/>
           </a:xfrm>
           <a:prstGeom prst="rect">
@@ -13670,7 +13769,7 @@
         </p:nvSpPr>
         <p:spPr>
           <a:xfrm>
-            <a:off x="411480" y="4983479"/>
+            <a:off x="411480" y="5193791"/>
             <a:ext cx="11503152" cy="548640"/>
           </a:xfrm>
           <a:prstGeom prst="rect">
@@ -13725,7 +13824,11 @@
             <p:ph idx="1"/>
           </p:nvPr>
         </p:nvSpPr>
-        <p:spPr/>
+        <p:spPr>
+          <a:xfrm>
+            <a:off x="0" y="1603063"/>
+          </a:xfrm>
+        </p:spPr>
         <p:txBody>
           <a:bodyPr/>
           <a:lstStyle/>
@@ -13742,7 +13845,11 @@
             <p:ph idx="2" sz="half"/>
           </p:nvPr>
         </p:nvSpPr>
-        <p:spPr/>
+        <p:spPr>
+          <a:xfrm>
+            <a:off x="0" y="1985790"/>
+          </a:xfrm>
+        </p:spPr>
         <p:txBody>
           <a:bodyPr/>
           <a:lstStyle/>
@@ -13948,7 +14055,7 @@
         </p:nvSpPr>
         <p:spPr>
           <a:xfrm>
-            <a:off x="274320" y="1051560"/>
+            <a:off x="274320" y="1261872"/>
             <a:ext cx="5760720" cy="411480"/>
           </a:xfrm>
           <a:prstGeom prst="rect">
@@ -13983,7 +14090,7 @@
         </p:nvSpPr>
         <p:spPr>
           <a:xfrm>
-            <a:off x="274320" y="1435607"/>
+            <a:off x="274320" y="1645919"/>
             <a:ext cx="5760720" cy="32004"/>
           </a:xfrm>
           <a:prstGeom prst="rect">
@@ -14026,7 +14133,7 @@
         </p:nvSpPr>
         <p:spPr>
           <a:xfrm>
-            <a:off x="274320" y="1527048"/>
+            <a:off x="274320" y="1737360"/>
             <a:ext cx="5760720" cy="4617720"/>
           </a:xfrm>
           <a:prstGeom prst="rect">
@@ -14145,7 +14252,7 @@
         </p:nvSpPr>
         <p:spPr>
           <a:xfrm>
-            <a:off x="6126480" y="1051560"/>
+            <a:off x="6126480" y="1261872"/>
             <a:ext cx="36576" cy="5120640"/>
           </a:xfrm>
           <a:prstGeom prst="rect">
@@ -14188,7 +14295,7 @@
         </p:nvSpPr>
         <p:spPr>
           <a:xfrm>
-            <a:off x="6291072" y="1051560"/>
+            <a:off x="6291072" y="1261872"/>
             <a:ext cx="5623560" cy="411480"/>
           </a:xfrm>
           <a:prstGeom prst="rect">
@@ -14223,7 +14330,7 @@
         </p:nvSpPr>
         <p:spPr>
           <a:xfrm>
-            <a:off x="6291072" y="1435607"/>
+            <a:off x="6291072" y="1645919"/>
             <a:ext cx="5623560" cy="32004"/>
           </a:xfrm>
           <a:prstGeom prst="rect">
@@ -14266,7 +14373,7 @@
         </p:nvSpPr>
         <p:spPr>
           <a:xfrm>
-            <a:off x="6291072" y="1527048"/>
+            <a:off x="6291072" y="1737360"/>
             <a:ext cx="5623560" cy="4617720"/>
           </a:xfrm>
           <a:prstGeom prst="rect">
@@ -14405,7 +14512,11 @@
             <p:ph idx="1"/>
           </p:nvPr>
         </p:nvSpPr>
-        <p:spPr/>
+        <p:spPr>
+          <a:xfrm>
+            <a:off x="0" y="1603063"/>
+          </a:xfrm>
+        </p:spPr>
         <p:txBody>
           <a:bodyPr/>
           <a:lstStyle/>
@@ -14422,7 +14533,11 @@
             <p:ph idx="2" sz="half"/>
           </p:nvPr>
         </p:nvSpPr>
-        <p:spPr/>
+        <p:spPr>
+          <a:xfrm>
+            <a:off x="0" y="1985790"/>
+          </a:xfrm>
+        </p:spPr>
         <p:txBody>
           <a:bodyPr/>
           <a:lstStyle/>
@@ -14628,7 +14743,7 @@
         </p:nvSpPr>
         <p:spPr>
           <a:xfrm>
-            <a:off x="274320" y="1051560"/>
+            <a:off x="274320" y="1261872"/>
             <a:ext cx="1828800" cy="1005840"/>
           </a:xfrm>
           <a:prstGeom prst="rect">
@@ -14671,7 +14786,7 @@
         </p:nvSpPr>
         <p:spPr>
           <a:xfrm>
-            <a:off x="292608" y="1280160"/>
+            <a:off x="292608" y="1490472"/>
             <a:ext cx="1810512" cy="594360"/>
           </a:xfrm>
           <a:prstGeom prst="rect">
@@ -14706,7 +14821,7 @@
         </p:nvSpPr>
         <p:spPr>
           <a:xfrm>
-            <a:off x="2148840" y="1051560"/>
+            <a:off x="2148840" y="1261872"/>
             <a:ext cx="9811512" cy="1005840"/>
           </a:xfrm>
           <a:prstGeom prst="rect">
@@ -14749,7 +14864,7 @@
         </p:nvSpPr>
         <p:spPr>
           <a:xfrm>
-            <a:off x="2240280" y="1161288"/>
+            <a:off x="2240280" y="1371600"/>
             <a:ext cx="9628632" cy="804672"/>
           </a:xfrm>
           <a:prstGeom prst="rect">
@@ -14785,7 +14900,7 @@
         </p:nvSpPr>
         <p:spPr>
           <a:xfrm>
-            <a:off x="822960" y="2057400"/>
+            <a:off x="822960" y="2267712"/>
             <a:ext cx="502920" cy="164592"/>
           </a:xfrm>
           <a:prstGeom prst="rect">
@@ -14828,7 +14943,7 @@
         </p:nvSpPr>
         <p:spPr>
           <a:xfrm>
-            <a:off x="822960" y="2039112"/>
+            <a:off x="822960" y="2249424"/>
             <a:ext cx="502920" cy="201168"/>
           </a:xfrm>
           <a:prstGeom prst="rect">
@@ -14863,7 +14978,7 @@
         </p:nvSpPr>
         <p:spPr>
           <a:xfrm>
-            <a:off x="274320" y="2286000"/>
+            <a:off x="274320" y="2496312"/>
             <a:ext cx="1828800" cy="1005840"/>
           </a:xfrm>
           <a:prstGeom prst="rect">
@@ -14906,7 +15021,7 @@
         </p:nvSpPr>
         <p:spPr>
           <a:xfrm>
-            <a:off x="292608" y="2514600"/>
+            <a:off x="292608" y="2724912"/>
             <a:ext cx="1810512" cy="594360"/>
           </a:xfrm>
           <a:prstGeom prst="rect">
@@ -14941,7 +15056,7 @@
         </p:nvSpPr>
         <p:spPr>
           <a:xfrm>
-            <a:off x="2148840" y="2286000"/>
+            <a:off x="2148840" y="2496312"/>
             <a:ext cx="9811512" cy="1005840"/>
           </a:xfrm>
           <a:prstGeom prst="rect">
@@ -14984,7 +15099,7 @@
         </p:nvSpPr>
         <p:spPr>
           <a:xfrm>
-            <a:off x="2240280" y="2395728"/>
+            <a:off x="2240280" y="2606040"/>
             <a:ext cx="9628632" cy="804672"/>
           </a:xfrm>
           <a:prstGeom prst="rect">
@@ -15020,7 +15135,7 @@
         </p:nvSpPr>
         <p:spPr>
           <a:xfrm>
-            <a:off x="822960" y="3291840"/>
+            <a:off x="822960" y="3502152"/>
             <a:ext cx="502920" cy="164592"/>
           </a:xfrm>
           <a:prstGeom prst="rect">
@@ -15063,7 +15178,7 @@
         </p:nvSpPr>
         <p:spPr>
           <a:xfrm>
-            <a:off x="822960" y="3273552"/>
+            <a:off x="822960" y="3483864"/>
             <a:ext cx="502920" cy="201168"/>
           </a:xfrm>
           <a:prstGeom prst="rect">
@@ -15098,7 +15213,7 @@
         </p:nvSpPr>
         <p:spPr>
           <a:xfrm>
-            <a:off x="274320" y="3520440"/>
+            <a:off x="274320" y="3730752"/>
             <a:ext cx="1828800" cy="1005840"/>
           </a:xfrm>
           <a:prstGeom prst="rect">
@@ -15141,7 +15256,7 @@
         </p:nvSpPr>
         <p:spPr>
           <a:xfrm>
-            <a:off x="292608" y="3749039"/>
+            <a:off x="292608" y="3959351"/>
             <a:ext cx="1810512" cy="594360"/>
           </a:xfrm>
           <a:prstGeom prst="rect">
@@ -15176,7 +15291,7 @@
         </p:nvSpPr>
         <p:spPr>
           <a:xfrm>
-            <a:off x="2148840" y="3520440"/>
+            <a:off x="2148840" y="3730752"/>
             <a:ext cx="9811512" cy="1005840"/>
           </a:xfrm>
           <a:prstGeom prst="rect">
@@ -15219,7 +15334,7 @@
         </p:nvSpPr>
         <p:spPr>
           <a:xfrm>
-            <a:off x="2240280" y="3630168"/>
+            <a:off x="2240280" y="3840480"/>
             <a:ext cx="9628632" cy="804672"/>
           </a:xfrm>
           <a:prstGeom prst="rect">
@@ -15255,7 +15370,7 @@
         </p:nvSpPr>
         <p:spPr>
           <a:xfrm>
-            <a:off x="274320" y="4828032"/>
+            <a:off x="274320" y="5038344"/>
             <a:ext cx="11686032" cy="685800"/>
           </a:xfrm>
           <a:prstGeom prst="rect">
@@ -15298,7 +15413,7 @@
         </p:nvSpPr>
         <p:spPr>
           <a:xfrm>
-            <a:off x="411480" y="4873752"/>
+            <a:off x="411480" y="5084064"/>
             <a:ext cx="11503152" cy="594360"/>
           </a:xfrm>
           <a:prstGeom prst="rect">
@@ -15353,7 +15468,11 @@
             <p:ph idx="1"/>
           </p:nvPr>
         </p:nvSpPr>
-        <p:spPr/>
+        <p:spPr>
+          <a:xfrm>
+            <a:off x="0" y="1603063"/>
+          </a:xfrm>
+        </p:spPr>
         <p:txBody>
           <a:bodyPr/>
           <a:lstStyle/>
@@ -15370,7 +15489,11 @@
             <p:ph idx="2" sz="half"/>
           </p:nvPr>
         </p:nvSpPr>
-        <p:spPr/>
+        <p:spPr>
+          <a:xfrm>
+            <a:off x="0" y="1985790"/>
+          </a:xfrm>
+        </p:spPr>
         <p:txBody>
           <a:bodyPr/>
           <a:lstStyle/>
@@ -15576,7 +15699,7 @@
         </p:nvSpPr>
         <p:spPr>
           <a:xfrm>
-            <a:off x="274320" y="1051560"/>
+            <a:off x="274320" y="1261872"/>
             <a:ext cx="5760720" cy="411480"/>
           </a:xfrm>
           <a:prstGeom prst="rect">
@@ -15611,7 +15734,7 @@
         </p:nvSpPr>
         <p:spPr>
           <a:xfrm>
-            <a:off x="274320" y="1435607"/>
+            <a:off x="274320" y="1645919"/>
             <a:ext cx="5760720" cy="32004"/>
           </a:xfrm>
           <a:prstGeom prst="rect">
@@ -15654,7 +15777,7 @@
         </p:nvSpPr>
         <p:spPr>
           <a:xfrm>
-            <a:off x="274320" y="1527048"/>
+            <a:off x="274320" y="1737360"/>
             <a:ext cx="5760720" cy="4617720"/>
           </a:xfrm>
           <a:prstGeom prst="rect">
@@ -15773,7 +15896,7 @@
         </p:nvSpPr>
         <p:spPr>
           <a:xfrm>
-            <a:off x="6126480" y="1051560"/>
+            <a:off x="6126480" y="1261872"/>
             <a:ext cx="36576" cy="5120640"/>
           </a:xfrm>
           <a:prstGeom prst="rect">
@@ -15816,7 +15939,7 @@
         </p:nvSpPr>
         <p:spPr>
           <a:xfrm>
-            <a:off x="6291072" y="1051560"/>
+            <a:off x="6291072" y="1261872"/>
             <a:ext cx="5623560" cy="411480"/>
           </a:xfrm>
           <a:prstGeom prst="rect">
@@ -15851,7 +15974,7 @@
         </p:nvSpPr>
         <p:spPr>
           <a:xfrm>
-            <a:off x="6291072" y="1435607"/>
+            <a:off x="6291072" y="1645919"/>
             <a:ext cx="5623560" cy="32004"/>
           </a:xfrm>
           <a:prstGeom prst="rect">
@@ -15894,7 +16017,7 @@
         </p:nvSpPr>
         <p:spPr>
           <a:xfrm>
-            <a:off x="6291072" y="1527048"/>
+            <a:off x="6291072" y="1737360"/>
             <a:ext cx="5623560" cy="4617720"/>
           </a:xfrm>
           <a:prstGeom prst="rect">

</xml_diff>